<commit_message>
Screeny live do decka HackYeah: powódź, pożar i preview budowy.
Co-authored-by: Cursor <cursoragent@cursor.com>
</commit_message>
<xml_diff>
--- a/docs/hackyeah-2026/KRAKOPOLIS-HackYeah-2026.pptx
+++ b/docs/hackyeah-2026/KRAKOPOLIS-HackYeah-2026.pptx
@@ -6550,8 +6550,8 @@
         </p:nvSpPr>
         <p:spPr>
           <a:xfrm>
-            <a:off x="411480" y="182880"/>
-            <a:ext cx="5486400" cy="274320"/>
+            <a:off x="365760" y="164592"/>
+            <a:ext cx="10972800" cy="256032"/>
           </a:xfrm>
           <a:prstGeom prst="rect">
             <a:avLst/>
@@ -6585,25 +6585,21 @@
         </p:nvSpPr>
         <p:spPr>
           <a:xfrm>
-            <a:off x="411480" y="457200"/>
-            <a:ext cx="5486400" cy="914400"/>
-          </a:xfrm>
-          <a:prstGeom prst="rect">
-            <a:avLst/>
-          </a:prstGeom>
-          <a:noFill/>
-        </p:spPr>
-        <p:txBody>
-          <a:bodyPr wrap="square">
-            <a:spAutoFit/>
-          </a:bodyPr>
-          <a:lstStyle/>
-          <a:p>
-            <a:pPr algn="l">
-              <a:spcAft>
-                <a:spcPts val="200"/>
-              </a:spcAft>
-            </a:pPr>
+            <a:off x="365760" y="411480"/>
+            <a:ext cx="10972800" cy="411480"/>
+          </a:xfrm>
+          <a:prstGeom prst="rect">
+            <a:avLst/>
+          </a:prstGeom>
+          <a:noFill/>
+        </p:spPr>
+        <p:txBody>
+          <a:bodyPr wrap="square">
+            <a:spAutoFit/>
+          </a:bodyPr>
+          <a:lstStyle/>
+          <a:p>
+            <a:pPr algn="l"/>
             <a:r>
               <a:rPr sz="2800" b="1">
                 <a:solidFill>
@@ -6611,37 +6607,69 @@
                 </a:solidFill>
                 <a:latin typeface="Arial"/>
               </a:rPr>
-              <a:t>Disasters are events,</a:t>
-            </a:r>
-          </a:p>
-          <a:p>
-            <a:pPr algn="l">
-              <a:spcAft>
-                <a:spcPts val="200"/>
-              </a:spcAft>
-            </a:pPr>
-            <a:r>
-              <a:rPr sz="2800" b="1">
-                <a:solidFill>
-                  <a:srgbClr val="F2F4F7"/>
-                </a:solidFill>
-                <a:latin typeface="Arial"/>
-              </a:rPr>
-              <a:t>not animations.</a:t>
-            </a:r>
-          </a:p>
-        </p:txBody>
-      </p:sp>
-      <p:sp>
-        <p:nvSpPr>
-          <p:cNvPr id="4" name="Rectangle 3"/>
+              <a:t>Disasters are events, not animations.</a:t>
+            </a:r>
+          </a:p>
+        </p:txBody>
+      </p:sp>
+      <p:pic>
+        <p:nvPicPr>
+          <p:cNvPr id="4" name="Picture 3" descr="s6-fire.jpg"/>
+          <p:cNvPicPr>
+            <a:picLocks noChangeAspect="1"/>
+          </p:cNvPicPr>
+          <p:nvPr/>
+        </p:nvPicPr>
+        <p:blipFill>
+          <a:blip r:embed="rId2"/>
+          <a:stretch>
+            <a:fillRect/>
+          </a:stretch>
+        </p:blipFill>
+        <p:spPr>
+          <a:xfrm>
+            <a:off x="365760" y="1051560"/>
+            <a:ext cx="5669280" cy="3549206"/>
+          </a:xfrm>
+          <a:prstGeom prst="rect">
+            <a:avLst/>
+          </a:prstGeom>
+        </p:spPr>
+      </p:pic>
+      <p:pic>
+        <p:nvPicPr>
+          <p:cNvPr id="5" name="Picture 4" descr="s6-flood.jpg"/>
+          <p:cNvPicPr>
+            <a:picLocks noChangeAspect="1"/>
+          </p:cNvPicPr>
+          <p:nvPr/>
+        </p:nvPicPr>
+        <p:blipFill>
+          <a:blip r:embed="rId3"/>
+          <a:stretch>
+            <a:fillRect/>
+          </a:stretch>
+        </p:blipFill>
+        <p:spPr>
+          <a:xfrm>
+            <a:off x="6172200" y="1051560"/>
+            <a:ext cx="5669280" cy="3549206"/>
+          </a:xfrm>
+          <a:prstGeom prst="rect">
+            <a:avLst/>
+          </a:prstGeom>
+        </p:spPr>
+      </p:pic>
+      <p:sp>
+        <p:nvSpPr>
+          <p:cNvPr id="6" name="Rectangle 5"/>
           <p:cNvSpPr/>
           <p:nvPr/>
         </p:nvSpPr>
         <p:spPr>
           <a:xfrm>
-            <a:off x="411480" y="1600200"/>
-            <a:ext cx="1325880" cy="1371600"/>
+            <a:off x="365760" y="4617720"/>
+            <a:ext cx="5669280" cy="1417320"/>
           </a:xfrm>
           <a:prstGeom prst="rect">
             <a:avLst/>
@@ -6677,84 +6705,14 @@
       </p:sp>
       <p:sp>
         <p:nvSpPr>
-          <p:cNvPr id="5" name="TextBox 4"/>
-          <p:cNvSpPr txBox="1"/>
-          <p:nvPr/>
-        </p:nvSpPr>
-        <p:spPr>
-          <a:xfrm>
-            <a:off x="484632" y="1737360"/>
-            <a:ext cx="1188720" cy="320040"/>
-          </a:xfrm>
-          <a:prstGeom prst="rect">
-            <a:avLst/>
-          </a:prstGeom>
-          <a:noFill/>
-        </p:spPr>
-        <p:txBody>
-          <a:bodyPr wrap="square">
-            <a:spAutoFit/>
-          </a:bodyPr>
-          <a:lstStyle/>
-          <a:p>
-            <a:pPr algn="l"/>
-            <a:r>
-              <a:rPr sz="1200" b="1">
-                <a:solidFill>
-                  <a:srgbClr val="E86A3C"/>
-                </a:solidFill>
-                <a:latin typeface="Arial"/>
-              </a:rPr>
-              <a:t>EVENT</a:t>
-            </a:r>
-          </a:p>
-        </p:txBody>
-      </p:sp>
-      <p:sp>
-        <p:nvSpPr>
-          <p:cNvPr id="6" name="TextBox 5"/>
-          <p:cNvSpPr txBox="1"/>
-          <p:nvPr/>
-        </p:nvSpPr>
-        <p:spPr>
-          <a:xfrm>
-            <a:off x="484632" y="2148840"/>
-            <a:ext cx="1188720" cy="640080"/>
-          </a:xfrm>
-          <a:prstGeom prst="rect">
-            <a:avLst/>
-          </a:prstGeom>
-          <a:noFill/>
-        </p:spPr>
-        <p:txBody>
-          <a:bodyPr wrap="square">
-            <a:spAutoFit/>
-          </a:bodyPr>
-          <a:lstStyle/>
-          <a:p>
-            <a:pPr algn="l"/>
-            <a:r>
-              <a:rPr sz="1200" b="0">
-                <a:solidFill>
-                  <a:srgbClr val="9AA3AF"/>
-                </a:solidFill>
-                <a:latin typeface="Arial"/>
-              </a:rPr>
-              <a:t>Fire / flood point</a:t>
-            </a:r>
-          </a:p>
-        </p:txBody>
-      </p:sp>
-      <p:sp>
-        <p:nvSpPr>
           <p:cNvPr id="7" name="Rectangle 6"/>
           <p:cNvSpPr/>
           <p:nvPr/>
         </p:nvSpPr>
         <p:spPr>
           <a:xfrm>
-            <a:off x="1828800" y="1600200"/>
-            <a:ext cx="1325880" cy="1371600"/>
+            <a:off x="6172200" y="4617720"/>
+            <a:ext cx="5669280" cy="1417320"/>
           </a:xfrm>
           <a:prstGeom prst="rect">
             <a:avLst/>
@@ -6796,8 +6754,8 @@
         </p:nvSpPr>
         <p:spPr>
           <a:xfrm>
-            <a:off x="1901952" y="1737360"/>
-            <a:ext cx="1188720" cy="320040"/>
+            <a:off x="502920" y="4754880"/>
+            <a:ext cx="5394960" cy="320040"/>
           </a:xfrm>
           <a:prstGeom prst="rect">
             <a:avLst/>
@@ -6812,13 +6770,13 @@
           <a:p>
             <a:pPr algn="l"/>
             <a:r>
-              <a:rPr sz="1200" b="1">
+              <a:rPr sz="1600" b="1">
                 <a:solidFill>
                   <a:srgbClr val="E86A3C"/>
                 </a:solidFill>
                 <a:latin typeface="Arial"/>
               </a:rPr>
-              <a:t>IMPACT</a:t>
+              <a:t>FIRE · POŻAR</a:t>
             </a:r>
           </a:p>
         </p:txBody>
@@ -6831,8 +6789,8 @@
         </p:nvSpPr>
         <p:spPr>
           <a:xfrm>
-            <a:off x="1901952" y="2148840"/>
-            <a:ext cx="1188720" cy="640080"/>
+            <a:off x="502920" y="5074920"/>
+            <a:ext cx="5394960" cy="731520"/>
           </a:xfrm>
           <a:prstGeom prst="rect">
             <a:avLst/>
@@ -6847,57 +6805,49 @@
           <a:p>
             <a:pPr algn="l"/>
             <a:r>
-              <a:rPr sz="1200" b="0">
-                <a:solidFill>
-                  <a:srgbClr val="9AA3AF"/>
-                </a:solidFill>
-                <a:latin typeface="Arial"/>
-              </a:rPr>
-              <a:t>Roads · metrics</a:t>
-            </a:r>
-          </a:p>
-        </p:txBody>
-      </p:sp>
-      <p:sp>
-        <p:nvSpPr>
-          <p:cNvPr id="10" name="Rectangle 9"/>
-          <p:cNvSpPr/>
-          <p:nvPr/>
-        </p:nvSpPr>
-        <p:spPr>
-          <a:xfrm>
-            <a:off x="3246120" y="1600200"/>
-            <a:ext cx="1325880" cy="1371600"/>
-          </a:xfrm>
-          <a:prstGeom prst="rect">
-            <a:avLst/>
-          </a:prstGeom>
-          <a:solidFill>
-            <a:srgbClr val="1A1E24"/>
-          </a:solidFill>
-          <a:ln>
-            <a:noFill/>
-          </a:ln>
-        </p:spPr>
-        <p:style>
-          <a:lnRef idx="1">
-            <a:schemeClr val="accent1"/>
-          </a:lnRef>
-          <a:fillRef idx="3">
-            <a:schemeClr val="accent1"/>
-          </a:fillRef>
-          <a:effectRef idx="2">
-            <a:schemeClr val="accent1"/>
-          </a:effectRef>
-          <a:fontRef idx="minor">
-            <a:schemeClr val="lt1"/>
-          </a:fontRef>
-        </p:style>
-        <p:txBody>
-          <a:bodyPr rtlCol="0" anchor="ctr"/>
-          <a:lstStyle/>
-          <a:p>
-            <a:pPr algn="ctr"/>
+              <a:rPr sz="1300" b="0">
+                <a:solidFill>
+                  <a:srgbClr val="F2F4F7"/>
+                </a:solidFill>
+                <a:latin typeface="Arial"/>
+              </a:rPr>
+              <a:t>Exact click location · roads &amp; metrics shift · MODEL ESTIMATE for people in range</a:t>
+            </a:r>
+          </a:p>
+        </p:txBody>
+      </p:sp>
+      <p:sp>
+        <p:nvSpPr>
+          <p:cNvPr id="10" name="TextBox 9"/>
+          <p:cNvSpPr txBox="1"/>
+          <p:nvPr/>
+        </p:nvSpPr>
+        <p:spPr>
+          <a:xfrm>
+            <a:off x="6309360" y="4754880"/>
+            <a:ext cx="5394960" cy="320040"/>
+          </a:xfrm>
+          <a:prstGeom prst="rect">
+            <a:avLst/>
+          </a:prstGeom>
+          <a:noFill/>
+        </p:spPr>
+        <p:txBody>
+          <a:bodyPr wrap="square">
+            <a:spAutoFit/>
+          </a:bodyPr>
+          <a:lstStyle/>
+          <a:p>
+            <a:pPr algn="l"/>
+            <a:r>
+              <a:rPr sz="1600" b="1">
+                <a:solidFill>
+                  <a:srgbClr val="4AA3C7"/>
+                </a:solidFill>
+                <a:latin typeface="Arial"/>
+              </a:rPr>
+              <a:t>FLOOD · POWÓDŹ</a:t>
+            </a:r>
           </a:p>
         </p:txBody>
       </p:sp>
@@ -6909,8 +6859,8 @@
         </p:nvSpPr>
         <p:spPr>
           <a:xfrm>
-            <a:off x="3319272" y="1737360"/>
-            <a:ext cx="1188720" cy="320040"/>
+            <a:off x="6309360" y="5074920"/>
+            <a:ext cx="5394960" cy="731520"/>
           </a:xfrm>
           <a:prstGeom prst="rect">
             <a:avLst/>
@@ -6925,13 +6875,13 @@
           <a:p>
             <a:pPr algn="l"/>
             <a:r>
-              <a:rPr sz="1200" b="1">
-                <a:solidFill>
-                  <a:srgbClr val="E86A3C"/>
-                </a:solidFill>
-                <a:latin typeface="Arial"/>
-              </a:rPr>
-              <a:t>RESPONSE</a:t>
+              <a:rPr sz="1300" b="0">
+                <a:solidFill>
+                  <a:srgbClr val="F2F4F7"/>
+                </a:solidFill>
+                <a:latin typeface="Arial"/>
+              </a:rPr>
+              <a:t>Water starts at the chosen point · spreads · closes access · SIMULATED impact</a:t>
             </a:r>
           </a:p>
         </p:txBody>
@@ -6939,265 +6889,6 @@
       <p:sp>
         <p:nvSpPr>
           <p:cNvPr id="12" name="TextBox 11"/>
-          <p:cNvSpPr txBox="1"/>
-          <p:nvPr/>
-        </p:nvSpPr>
-        <p:spPr>
-          <a:xfrm>
-            <a:off x="3319272" y="2148840"/>
-            <a:ext cx="1188720" cy="640080"/>
-          </a:xfrm>
-          <a:prstGeom prst="rect">
-            <a:avLst/>
-          </a:prstGeom>
-          <a:noFill/>
-        </p:spPr>
-        <p:txBody>
-          <a:bodyPr wrap="square">
-            <a:spAutoFit/>
-          </a:bodyPr>
-          <a:lstStyle/>
-          <a:p>
-            <a:pPr algn="l"/>
-            <a:r>
-              <a:rPr sz="1200" b="0">
-                <a:solidFill>
-                  <a:srgbClr val="9AA3AF"/>
-                </a:solidFill>
-                <a:latin typeface="Arial"/>
-              </a:rPr>
-              <a:t>City state updates</a:t>
-            </a:r>
-          </a:p>
-        </p:txBody>
-      </p:sp>
-      <p:sp>
-        <p:nvSpPr>
-          <p:cNvPr id="13" name="Rectangle 12"/>
-          <p:cNvSpPr/>
-          <p:nvPr/>
-        </p:nvSpPr>
-        <p:spPr>
-          <a:xfrm>
-            <a:off x="4663440" y="1600200"/>
-            <a:ext cx="1325880" cy="1371600"/>
-          </a:xfrm>
-          <a:prstGeom prst="rect">
-            <a:avLst/>
-          </a:prstGeom>
-          <a:solidFill>
-            <a:srgbClr val="1A1E24"/>
-          </a:solidFill>
-          <a:ln>
-            <a:noFill/>
-          </a:ln>
-        </p:spPr>
-        <p:style>
-          <a:lnRef idx="1">
-            <a:schemeClr val="accent1"/>
-          </a:lnRef>
-          <a:fillRef idx="3">
-            <a:schemeClr val="accent1"/>
-          </a:fillRef>
-          <a:effectRef idx="2">
-            <a:schemeClr val="accent1"/>
-          </a:effectRef>
-          <a:fontRef idx="minor">
-            <a:schemeClr val="lt1"/>
-          </a:fontRef>
-        </p:style>
-        <p:txBody>
-          <a:bodyPr rtlCol="0" anchor="ctr"/>
-          <a:lstStyle/>
-          <a:p>
-            <a:pPr algn="ctr"/>
-          </a:p>
-        </p:txBody>
-      </p:sp>
-      <p:sp>
-        <p:nvSpPr>
-          <p:cNvPr id="14" name="TextBox 13"/>
-          <p:cNvSpPr txBox="1"/>
-          <p:nvPr/>
-        </p:nvSpPr>
-        <p:spPr>
-          <a:xfrm>
-            <a:off x="4736592" y="1737360"/>
-            <a:ext cx="1188720" cy="320040"/>
-          </a:xfrm>
-          <a:prstGeom prst="rect">
-            <a:avLst/>
-          </a:prstGeom>
-          <a:noFill/>
-        </p:spPr>
-        <p:txBody>
-          <a:bodyPr wrap="square">
-            <a:spAutoFit/>
-          </a:bodyPr>
-          <a:lstStyle/>
-          <a:p>
-            <a:pPr algn="l"/>
-            <a:r>
-              <a:rPr sz="1200" b="1">
-                <a:solidFill>
-                  <a:srgbClr val="E86A3C"/>
-                </a:solidFill>
-                <a:latin typeface="Arial"/>
-              </a:rPr>
-              <a:t>RECOVERY</a:t>
-            </a:r>
-          </a:p>
-        </p:txBody>
-      </p:sp>
-      <p:sp>
-        <p:nvSpPr>
-          <p:cNvPr id="15" name="TextBox 14"/>
-          <p:cNvSpPr txBox="1"/>
-          <p:nvPr/>
-        </p:nvSpPr>
-        <p:spPr>
-          <a:xfrm>
-            <a:off x="4736592" y="2148840"/>
-            <a:ext cx="1188720" cy="640080"/>
-          </a:xfrm>
-          <a:prstGeom prst="rect">
-            <a:avLst/>
-          </a:prstGeom>
-          <a:noFill/>
-        </p:spPr>
-        <p:txBody>
-          <a:bodyPr wrap="square">
-            <a:spAutoFit/>
-          </a:bodyPr>
-          <a:lstStyle/>
-          <a:p>
-            <a:pPr algn="l"/>
-            <a:r>
-              <a:rPr sz="1200" b="0">
-                <a:solidFill>
-                  <a:srgbClr val="9AA3AF"/>
-                </a:solidFill>
-                <a:latin typeface="Arial"/>
-              </a:rPr>
-              <a:t>Your next moves</a:t>
-            </a:r>
-          </a:p>
-        </p:txBody>
-      </p:sp>
-      <p:sp>
-        <p:nvSpPr>
-          <p:cNvPr id="16" name="TextBox 15"/>
-          <p:cNvSpPr txBox="1"/>
-          <p:nvPr/>
-        </p:nvSpPr>
-        <p:spPr>
-          <a:xfrm>
-            <a:off x="411480" y="3246120"/>
-            <a:ext cx="5486400" cy="2103120"/>
-          </a:xfrm>
-          <a:prstGeom prst="rect">
-            <a:avLst/>
-          </a:prstGeom>
-          <a:noFill/>
-        </p:spPr>
-        <p:txBody>
-          <a:bodyPr wrap="square">
-            <a:spAutoFit/>
-          </a:bodyPr>
-          <a:lstStyle/>
-          <a:p>
-            <a:pPr algn="l">
-              <a:spcAft>
-                <a:spcPts val="800"/>
-              </a:spcAft>
-            </a:pPr>
-            <a:r>
-              <a:rPr sz="1200" b="1">
-                <a:solidFill>
-                  <a:srgbClr val="E86A3C"/>
-                </a:solidFill>
-                <a:latin typeface="Arial"/>
-              </a:rPr>
-              <a:t>LIVE CAPTURE · FIRE</a:t>
-            </a:r>
-          </a:p>
-          <a:p>
-            <a:pPr algn="l">
-              <a:spcAft>
-                <a:spcPts val="800"/>
-              </a:spcAft>
-            </a:pPr>
-            <a:r>
-              <a:rPr sz="1600" b="0">
-                <a:solidFill>
-                  <a:srgbClr val="F2F4F7"/>
-                </a:solidFill>
-                <a:latin typeface="Arial"/>
-              </a:rPr>
-              <a:t>“Wykryto pożar.” on the map</a:t>
-            </a:r>
-          </a:p>
-          <a:p>
-            <a:pPr algn="l">
-              <a:spcAft>
-                <a:spcPts val="800"/>
-              </a:spcAft>
-            </a:pPr>
-            <a:r>
-              <a:rPr sz="1500" b="0">
-                <a:solidFill>
-                  <a:srgbClr val="F2F4F7"/>
-                </a:solidFill>
-                <a:latin typeface="Arial"/>
-              </a:rPr>
-              <a:t>SIMULATED road &amp; metric impact</a:t>
-            </a:r>
-          </a:p>
-          <a:p>
-            <a:pPr algn="l">
-              <a:spcAft>
-                <a:spcPts val="800"/>
-              </a:spcAft>
-            </a:pPr>
-            <a:r>
-              <a:rPr sz="1300" b="0">
-                <a:solidFill>
-                  <a:srgbClr val="9AA3AF"/>
-                </a:solidFill>
-                <a:latin typeface="Arial"/>
-              </a:rPr>
-              <a:t>People-in-radius = MODEL ESTIMATE (low confidence)</a:t>
-            </a:r>
-          </a:p>
-        </p:txBody>
-      </p:sp>
-      <p:pic>
-        <p:nvPicPr>
-          <p:cNvPr id="17" name="Picture 16" descr="s6-fire.jpg"/>
-          <p:cNvPicPr>
-            <a:picLocks noChangeAspect="1"/>
-          </p:cNvPicPr>
-          <p:nvPr/>
-        </p:nvPicPr>
-        <p:blipFill>
-          <a:blip r:embed="rId2"/>
-          <a:stretch>
-            <a:fillRect/>
-          </a:stretch>
-        </p:blipFill>
-        <p:spPr>
-          <a:xfrm>
-            <a:off x="6126480" y="320040"/>
-            <a:ext cx="5669280" cy="3549206"/>
-          </a:xfrm>
-          <a:prstGeom prst="rect">
-            <a:avLst/>
-          </a:prstGeom>
-        </p:spPr>
-      </p:pic>
-      <p:sp>
-        <p:nvSpPr>
-          <p:cNvPr id="18" name="TextBox 17"/>
           <p:cNvSpPr txBox="1"/>
           <p:nvPr/>
         </p:nvSpPr>
@@ -7232,7 +6923,7 @@
       </p:sp>
       <p:sp>
         <p:nvSpPr>
-          <p:cNvPr id="19" name="TextBox 18"/>
+          <p:cNvPr id="13" name="TextBox 12"/>
           <p:cNvSpPr txBox="1"/>
           <p:nvPr/>
         </p:nvSpPr>

</xml_diff>